<commit_message>
feat: upgrade CyberVaultX security intelligence UI and release workflow
- Added/updated security analysis modules and risk engine
- Improved dashboard, proof center, advisor, insights, and reporting UI
- Added product intelligence, backup, signing, and snapshot services
- Added release preflight checks and GitHub Actions test workflow
- Updated screenshots/assets for the latest interface
</commit_message>
<xml_diff>
--- a/presentation/CyberVaultX_Presentation.pptx
+++ b/presentation/CyberVaultX_Presentation.pptx
@@ -1944,7 +1944,7 @@
                   <a:srgbClr val="475467"/>
                 </a:solidFill>
               </a:rPr>
-              <a:t>Secure Password Manager with End-to-End Encryption</a:t>
+              <a:t>Secure Password Manager with Local Encryption at Rest</a:t>
             </a:r>
             <a:endParaRPr lang="en-US" sz="1500" dirty="0"/>
           </a:p>
@@ -2172,7 +2172,7 @@
                   <a:srgbClr val="0E7490"/>
                 </a:solidFill>
               </a:rPr>
-              <a:t>AI Guardian</a:t>
+              <a:t>AI-style Local Security Coach</a:t>
             </a:r>
             <a:endParaRPr lang="en-US" sz="850" dirty="0"/>
           </a:p>
@@ -2379,7 +2379,7 @@
                   <a:srgbClr val="475467"/>
                 </a:solidFill>
               </a:rPr>
-              <a:t>v5.6.0</a:t>
+              <a:t>v5.7.2</a:t>
             </a:r>
             <a:endParaRPr lang="en-US" sz="800" dirty="0"/>
           </a:p>
@@ -2615,7 +2615,7 @@
                   <a:srgbClr val="102033"/>
                 </a:solidFill>
               </a:rPr>
-              <a:t>Report signing</a:t>
+              <a:t>Local manifest integrity signature</a:t>
             </a:r>
             <a:endParaRPr lang="en-US" sz="1300" dirty="0"/>
           </a:p>
@@ -2653,7 +2653,7 @@
                   <a:srgbClr val="475467"/>
                 </a:solidFill>
               </a:rPr>
-              <a:t>HMAC proves local integrity. Future: Ed25519 public verification key for independent proof.</a:t>
+              <a:t>HMAC provides local manifest integrity. Future: Ed25519 public verification key for independent proof.</a:t>
             </a:r>
             <a:endParaRPr lang="en-US" sz="1020" dirty="0"/>
           </a:p>
@@ -2813,7 +2813,7 @@
                   <a:srgbClr val="102033"/>
                 </a:solidFill>
               </a:rPr>
-              <a:t>Commercial readiness</a:t>
+              <a:t>Commercial-style academic readiness</a:t>
             </a:r>
             <a:endParaRPr lang="en-US" sz="1300" dirty="0"/>
           </a:p>
@@ -2851,7 +2851,7 @@
                   <a:srgbClr val="475467"/>
                 </a:solidFill>
               </a:rPr>
-              <a:t>Academic prototype. Commercial version needs external audit, installer signing, and secure-memory hardening.</a:t>
+              <a:t>Commercial-style academic prototype. Future production version needs external audit, installer signing, and secure-memory hardening.</a:t>
             </a:r>
             <a:endParaRPr lang="en-US" sz="1020" dirty="0"/>
           </a:p>
@@ -3144,7 +3144,7 @@
                   <a:srgbClr val="475467"/>
                 </a:solidFill>
               </a:rPr>
-              <a:t>v5.6.0</a:t>
+              <a:t>v5.7.2</a:t>
             </a:r>
             <a:endParaRPr lang="en-US" sz="800" dirty="0"/>
           </a:p>
@@ -4240,7 +4240,7 @@
                   <a:srgbClr val="CBD5E1"/>
                 </a:solidFill>
               </a:rPr>
-              <a:t>Prepared answers cover AES-GCM, PBKDF2, AAD, breach detection, AI Guardian privacy, Tkinter choice, and project limitations.</a:t>
+              <a:t>Prepared answers cover AES-GCM, PBKDF2, AAD, offline demo breach-subset detection, AI-style Local Security Coach privacy, Tkinter choice, and project limitations.</a:t>
             </a:r>
             <a:endParaRPr lang="en-US" sz="1200" dirty="0"/>
           </a:p>
@@ -4435,7 +4435,7 @@
                   <a:srgbClr val="475467"/>
                 </a:solidFill>
               </a:rPr>
-              <a:t>v5.6.0</a:t>
+              <a:t>v5.7.2</a:t>
             </a:r>
             <a:endParaRPr lang="en-US" sz="800" dirty="0"/>
           </a:p>
@@ -5245,7 +5245,7 @@
                   <a:srgbClr val="475467"/>
                 </a:solidFill>
               </a:rPr>
-              <a:t>v5.6.0</a:t>
+              <a:t>v5.7.2</a:t>
             </a:r>
             <a:endParaRPr lang="en-US" sz="800" dirty="0"/>
           </a:p>
@@ -5517,7 +5517,7 @@
                   <a:srgbClr val="102033"/>
                 </a:solidFill>
               </a:rPr>
-              <a:t>AI Guardian</a:t>
+              <a:t>AI-style Local Security Coach</a:t>
             </a:r>
             <a:endParaRPr lang="en-US" sz="1300" dirty="0"/>
           </a:p>
@@ -6046,7 +6046,7 @@
                   <a:srgbClr val="475467"/>
                 </a:solidFill>
               </a:rPr>
-              <a:t>v5.6.0</a:t>
+              <a:t>v5.7.2</a:t>
             </a:r>
             <a:endParaRPr lang="en-US" sz="800" dirty="0"/>
           </a:p>
@@ -6485,7 +6485,7 @@
                   <a:srgbClr val="475467"/>
                 </a:solidFill>
               </a:rPr>
-              <a:t>AI Guardian</a:t>
+              <a:t>AI-style Local Security Coach</a:t>
             </a:r>
             <a:endParaRPr lang="en-US" sz="900" dirty="0"/>
           </a:p>
@@ -7120,7 +7120,7 @@
                   <a:srgbClr val="475467"/>
                 </a:solidFill>
               </a:rPr>
-              <a:t>v5.6.0</a:t>
+              <a:t>v5.7.2</a:t>
             </a:r>
             <a:endParaRPr lang="en-US" sz="800" dirty="0"/>
           </a:p>
@@ -8015,7 +8015,7 @@
                   <a:srgbClr val="475467"/>
                 </a:solidFill>
               </a:rPr>
-              <a:t>v5.6.0</a:t>
+              <a:t>v5.7.2</a:t>
             </a:r>
             <a:endParaRPr lang="en-US" sz="800" dirty="0"/>
           </a:p>
@@ -8350,7 +8350,7 @@
                   <a:srgbClr val="102033"/>
                 </a:solidFill>
               </a:rPr>
-              <a:t>Breach Detection</a:t>
+              <a:t>Offline Demo Breach-Subset Check</a:t>
             </a:r>
             <a:endParaRPr lang="en-US" sz="1220" dirty="0"/>
           </a:p>
@@ -8681,7 +8681,7 @@
                   <a:srgbClr val="475467"/>
                 </a:solidFill>
               </a:rPr>
-              <a:t>v5.6.0</a:t>
+              <a:t>v5.7.2</a:t>
             </a:r>
             <a:endParaRPr lang="en-US" sz="800" dirty="0"/>
           </a:p>
@@ -8719,7 +8719,7 @@
                   <a:srgbClr val="102033"/>
                 </a:solidFill>
               </a:rPr>
-              <a:t>AI Guardian</a:t>
+              <a:t>AI-style Local Security Coach</a:t>
             </a:r>
             <a:endParaRPr lang="en-US" sz="1300" dirty="0"/>
           </a:p>
@@ -9446,7 +9446,7 @@
                   <a:srgbClr val="475467"/>
                 </a:solidFill>
               </a:rPr>
-              <a:t>v5.6.0</a:t>
+              <a:t>v5.7.2</a:t>
             </a:r>
             <a:endParaRPr lang="en-US" sz="800" dirty="0"/>
           </a:p>
@@ -9852,7 +9852,7 @@
                   <a:srgbClr val="475467"/>
                 </a:solidFill>
               </a:rPr>
-              <a:t>AI Guardian payloads are redacted and privacy-safe</a:t>
+              <a:t>AI-style Local Security Coach payloads are redacted and privacy-safe</a:t>
             </a:r>
             <a:endParaRPr lang="en-US" sz="950" dirty="0"/>
           </a:p>
@@ -10281,7 +10281,7 @@
                   <a:srgbClr val="475467"/>
                 </a:solidFill>
               </a:rPr>
-              <a:t>v5.6.0</a:t>
+              <a:t>v5.7.2</a:t>
             </a:r>
             <a:endParaRPr lang="en-US" sz="800" dirty="0"/>
           </a:p>
@@ -10445,7 +10445,7 @@
                   <a:srgbClr val="102033"/>
                 </a:solidFill>
               </a:rPr>
-              <a:t>Load Professional Demo Vault</a:t>
+              <a:t>Create Assessment Workspace</a:t>
             </a:r>
             <a:endParaRPr lang="en-US" sz="1200" dirty="0"/>
           </a:p>
@@ -10691,7 +10691,7 @@
                   <a:srgbClr val="102033"/>
                 </a:solidFill>
               </a:rPr>
-              <a:t>Generate AI Guardian plan</a:t>
+              <a:t>Generate AI-style Local Security Coach plan</a:t>
             </a:r>
             <a:endParaRPr lang="en-US" sz="1200" dirty="0"/>
           </a:p>

</xml_diff>